<commit_message>
modificação na tela de registrar, para agilizar o processo.
</commit_message>
<xml_diff>
--- a/WEFIND - TCC/apresentacao_pptx/WEFIND_slide_arquitetura.pptx
+++ b/WEFIND - TCC/apresentacao_pptx/WEFIND_slide_arquitetura.pptx
@@ -6773,6 +6773,61 @@
           </p:spPr>
         </p:sp>
       </p:grpSp>
+      <p:sp>
+        <p:nvSpPr>
+          <p:cNvPr id="288" name="Oval 287"/>
+          <p:cNvSpPr/>
+          <p:nvPr/>
+        </p:nvSpPr>
+        <p:spPr>
+          <a:xfrm>
+            <a:off x="12508992" y="7863840"/>
+            <a:ext cx="292608" cy="292608"/>
+          </a:xfrm>
+          <a:prstGeom prst="ellipse">
+            <a:avLst/>
+          </a:prstGeom>
+          <a:solidFill>
+            <a:srgbClr val="E53E3E"/>
+          </a:solidFill>
+          <a:ln w="25400">
+            <a:solidFill>
+              <a:srgbClr val="FFFFFF"/>
+            </a:solidFill>
+          </a:ln>
+          <a:effectLst/>
+        </p:spPr>
+        <p:style>
+          <a:lnRef idx="1">
+            <a:schemeClr val="accent1"/>
+          </a:lnRef>
+          <a:fillRef idx="3">
+            <a:schemeClr val="accent1"/>
+          </a:fillRef>
+          <a:effectRef idx="2">
+            <a:schemeClr val="accent1"/>
+          </a:effectRef>
+          <a:fontRef idx="minor">
+            <a:schemeClr val="lt1"/>
+          </a:fontRef>
+        </p:style>
+        <p:txBody>
+          <a:bodyPr rtlCol="0" anchor="ctr" lIns="0" rIns="0" tIns="0" bIns="0"/>
+          <a:lstStyle/>
+          <a:p>
+            <a:pPr algn="ctr"/>
+            <a:r>
+              <a:rPr sz="1300" b="1">
+                <a:solidFill>
+                  <a:srgbClr val="FFFFFF"/>
+                </a:solidFill>
+                <a:latin typeface="Calibri (MS) Bold"/>
+              </a:rPr>
+              <a:t>1</a:t>
+            </a:r>
+          </a:p>
+        </p:txBody>
+      </p:sp>
     </p:spTree>
   </p:cSld>
   <p:clrMapOvr>

</xml_diff>